<commit_message>
Add project book report, academic figures, and presentation deliverables
- report/: LaTeX source (main.tex, references.bib), compiled main.pdf,
  and all academic figures under report/figures/
- report/figure_scripts/: make_figures.py + academic_style.py that
  regenerate the 8 report figures (6 data-driven, 2 ML-scored)
- outputs/evaluation/test_scores.npz: cached per-sample test scores
- Move workflow/architecture SVGs into outputs/
- Add presentation decks, poster, and speaker notes
- Archive old baseline/evaluation runs under outputs/_archive_old_runs/
- .gitignore: ignore LaTeX build artifacts, Office lock/temp files,
  and dataset .bak backups
</commit_message>
<xml_diff>
--- a/outputs/Final poster.pptx
+++ b/outputs/Final poster.pptx
@@ -5113,7 +5113,7 @@
         <p:spPr>
           <a:xfrm>
             <a:off x="382927" y="28161685"/>
-            <a:ext cx="31638195" cy="8693983"/>
+            <a:ext cx="31638195" cy="9242315"/>
           </a:xfrm>
           <a:prstGeom prst="roundRect">
             <a:avLst/>
@@ -6199,8 +6199,8 @@
         </p:nvSpPr>
         <p:spPr>
           <a:xfrm>
-            <a:off x="279822" y="37340291"/>
-            <a:ext cx="31638195" cy="5520255"/>
+            <a:off x="279822" y="37654786"/>
+            <a:ext cx="31638195" cy="5205760"/>
           </a:xfrm>
           <a:prstGeom prst="roundRect">
             <a:avLst/>
@@ -6316,8 +6316,12 @@
           <a:lstStyle/>
           <a:p>
             <a:r>
+              <a:rPr lang="en-IL" sz="4000" b="1" dirty="0"/>
+              <a:t>Bitcoin</a:t>
+            </a:r>
+            <a:r>
               <a:rPr lang="en-IL" sz="4000" dirty="0"/>
-              <a:t>Bitcoin is pseudonymous, making it a haven for scams, ransomware, and money laundering. Spotting criminal wallets is hard as they're rare, anonymous, and their behavior shows in </a:t>
+              <a:t> is pseudonymous, making it a haven for scams, ransomware, and money laundering. Spotting criminal wallets is hard as they're rare, anonymous, and their behavior shows in </a:t>
             </a:r>
             <a:r>
               <a:rPr lang="en-IL" sz="4000" i="1" dirty="0"/>
@@ -6332,7 +6336,18 @@
             </a:br>
             <a:r>
               <a:rPr lang="en-IL" sz="4000" dirty="0"/>
-              <a:t>Traditional models judge each wallet in isolation and miss this structure. We model the blockchain as a transaction graph and use a Graph Neural Network to learn from each wallet's neighborhood.</a:t>
+              <a:t>Traditional models judge each wallet in isolation and miss this structure. </a:t>
+            </a:r>
+            <a:br>
+              <a:rPr lang="en-IL" sz="4000" dirty="0"/>
+            </a:br>
+            <a:r>
+              <a:rPr lang="en-IL" sz="4000" b="1" dirty="0"/>
+              <a:t>We model </a:t>
+            </a:r>
+            <a:r>
+              <a:rPr lang="en-IL" sz="4000" dirty="0"/>
+              <a:t>the blockchain as a transaction graph and use a Graph Neural Network to learn from each wallet's neighborhood.</a:t>
             </a:r>
           </a:p>
           <a:p>
@@ -6388,7 +6403,7 @@
             </a:r>
             <a:r>
               <a:rPr lang="en-IL" sz="3200" dirty="0"/>
-              <a:t> from mempool.space — scores any address, even new ones </a:t>
+              <a:t> from mempool.space: scores any address, even new ones </a:t>
             </a:r>
           </a:p>
           <a:p>
@@ -6398,11 +6413,11 @@
             </a:pPr>
             <a:r>
               <a:rPr lang="en-IL" sz="3200" b="1" dirty="0"/>
-              <a:t>Graph beats tables</a:t>
+              <a:t>Graph beats tables: </a:t>
             </a:r>
             <a:r>
               <a:rPr lang="en-IL" sz="3200" dirty="0"/>
-              <a:t> — GATv2 attention catches relational signal tabular models miss; ghost nodes handle sparse wallets </a:t>
+              <a:t>GATv2 attention catches relational signal tabular models miss; ghost nodes handle sparse wallets </a:t>
             </a:r>
           </a:p>
           <a:p>
@@ -6416,7 +6431,7 @@
             </a:r>
             <a:r>
               <a:rPr lang="en-IL" sz="3200" dirty="0"/>
-              <a:t>, not just a label — trustworthy probability (ROC-AUC 0.958)</a:t>
+              <a:t>, not just a label, model produces trustworthy probability.</a:t>
             </a:r>
           </a:p>
         </p:txBody>
@@ -6450,8 +6465,12 @@
           <a:lstStyle/>
           <a:p>
             <a:r>
+              <a:rPr lang="en-IL" sz="4000" b="1" dirty="0"/>
+              <a:t>Modeling</a:t>
+            </a:r>
+            <a:r>
               <a:rPr lang="en-IL" sz="4000" dirty="0"/>
-              <a:t>Modeling the blockchain as a graph clearly pays off as GATv2 beats both baselines on every metric and the calibrated confidence scores make the output usable as a real risk-screening signal, not just a label.</a:t>
+              <a:t> the blockchain as a graph clearly pays off as GATv2 beats both baselines on every metric and the calibrated confidence scores make the output usable as a real risk-screening signal, not just a label.</a:t>
             </a:r>
           </a:p>
           <a:p>
@@ -6575,7 +6594,7 @@
         </p:blipFill>
         <p:spPr>
           <a:xfrm>
-            <a:off x="1302753" y="21064138"/>
+            <a:off x="1437056" y="20171181"/>
             <a:ext cx="17508810" cy="6511088"/>
           </a:xfrm>
           <a:prstGeom prst="rect">
@@ -6683,7 +6702,7 @@
         </p:blipFill>
         <p:spPr>
           <a:xfrm>
-            <a:off x="688206" y="29546128"/>
+            <a:off x="679467" y="28960803"/>
             <a:ext cx="13084368" cy="7276511"/>
           </a:xfrm>
           <a:prstGeom prst="rect">
@@ -6719,7 +6738,7 @@
         </p:blipFill>
         <p:spPr>
           <a:xfrm>
-            <a:off x="13763835" y="29705683"/>
+            <a:off x="13836491" y="29378829"/>
             <a:ext cx="10218749" cy="6764523"/>
           </a:xfrm>
           <a:prstGeom prst="rect">
@@ -6755,7 +6774,7 @@
         </p:blipFill>
         <p:spPr>
           <a:xfrm>
-            <a:off x="24424553" y="29546128"/>
+            <a:off x="24437481" y="29221581"/>
             <a:ext cx="6643368" cy="6764523"/>
           </a:xfrm>
           <a:prstGeom prst="rect">
@@ -6838,7 +6857,7 @@
         </p:nvSpPr>
         <p:spPr>
           <a:xfrm>
-            <a:off x="7400052" y="19285454"/>
+            <a:off x="7534355" y="19058416"/>
             <a:ext cx="5314212" cy="923330"/>
           </a:xfrm>
           <a:prstGeom prst="rect">
@@ -7004,6 +7023,160 @@
                 </a:outerShdw>
               </a:effectLst>
             </a:endParaRPr>
+          </a:p>
+        </p:txBody>
+      </p:sp>
+      <p:sp>
+        <p:nvSpPr>
+          <p:cNvPr id="42" name="TextBox 41">
+            <a:extLst>
+              <a:ext uri="{FF2B5EF4-FFF2-40B4-BE49-F238E27FC236}">
+                <a16:creationId xmlns:a16="http://schemas.microsoft.com/office/drawing/2014/main" id="{FEBB9F02-69B6-E0C6-8885-CD0BC30DA7AE}"/>
+              </a:ext>
+            </a:extLst>
+          </p:cNvPr>
+          <p:cNvSpPr txBox="1"/>
+          <p:nvPr/>
+        </p:nvSpPr>
+        <p:spPr>
+          <a:xfrm>
+            <a:off x="2228519" y="36202231"/>
+            <a:ext cx="10611671" cy="954107"/>
+          </a:xfrm>
+          <a:prstGeom prst="rect">
+            <a:avLst/>
+          </a:prstGeom>
+          <a:noFill/>
+        </p:spPr>
+        <p:txBody>
+          <a:bodyPr wrap="square" rtlCol="0">
+            <a:spAutoFit/>
+          </a:bodyPr>
+          <a:lstStyle/>
+          <a:p>
+            <a:r>
+              <a:rPr lang="en-IL" sz="2800" dirty="0"/>
+              <a:t>Our GNN beats both baselines on every metric, with its biggest lead in recall, catching far more criminal wallets.</a:t>
+            </a:r>
+          </a:p>
+        </p:txBody>
+      </p:sp>
+      <p:sp>
+        <p:nvSpPr>
+          <p:cNvPr id="43" name="TextBox 42">
+            <a:extLst>
+              <a:ext uri="{FF2B5EF4-FFF2-40B4-BE49-F238E27FC236}">
+                <a16:creationId xmlns:a16="http://schemas.microsoft.com/office/drawing/2014/main" id="{AB03DF3A-FC3D-1EDD-FBAB-DA660D8E021C}"/>
+              </a:ext>
+            </a:extLst>
+          </p:cNvPr>
+          <p:cNvSpPr txBox="1"/>
+          <p:nvPr/>
+        </p:nvSpPr>
+        <p:spPr>
+          <a:xfrm>
+            <a:off x="15335456" y="36196130"/>
+            <a:ext cx="7921289" cy="954107"/>
+          </a:xfrm>
+          <a:prstGeom prst="rect">
+            <a:avLst/>
+          </a:prstGeom>
+          <a:noFill/>
+        </p:spPr>
+        <p:txBody>
+          <a:bodyPr wrap="square" rtlCol="0">
+            <a:spAutoFit/>
+          </a:bodyPr>
+          <a:lstStyle/>
+          <a:p>
+            <a:r>
+              <a:rPr lang="en-IL" sz="2800" dirty="0"/>
+              <a:t>most predictions land at high confidence </a:t>
+            </a:r>
+            <a:br>
+              <a:rPr lang="en-IL" sz="2800" dirty="0"/>
+            </a:br>
+            <a:r>
+              <a:rPr lang="en-IL" sz="2800" dirty="0"/>
+              <a:t>so the risk score is decisive yet well-calibrated.</a:t>
+            </a:r>
+          </a:p>
+        </p:txBody>
+      </p:sp>
+      <p:sp>
+        <p:nvSpPr>
+          <p:cNvPr id="44" name="TextBox 43">
+            <a:extLst>
+              <a:ext uri="{FF2B5EF4-FFF2-40B4-BE49-F238E27FC236}">
+                <a16:creationId xmlns:a16="http://schemas.microsoft.com/office/drawing/2014/main" id="{99D125A6-1125-404F-AF7D-57C3D639A810}"/>
+              </a:ext>
+            </a:extLst>
+          </p:cNvPr>
+          <p:cNvSpPr txBox="1"/>
+          <p:nvPr/>
+        </p:nvSpPr>
+        <p:spPr>
+          <a:xfrm>
+            <a:off x="23996727" y="36196129"/>
+            <a:ext cx="7921290" cy="954107"/>
+          </a:xfrm>
+          <a:prstGeom prst="rect">
+            <a:avLst/>
+          </a:prstGeom>
+          <a:noFill/>
+        </p:spPr>
+        <p:txBody>
+          <a:bodyPr wrap="square" rtlCol="0">
+            <a:spAutoFit/>
+          </a:bodyPr>
+          <a:lstStyle/>
+          <a:p>
+            <a:r>
+              <a:rPr lang="en-IL" sz="2800" dirty="0"/>
+              <a:t>Our GNN separates criminal from benign wallets </a:t>
+            </a:r>
+            <a:br>
+              <a:rPr lang="en-IL" sz="2800" dirty="0"/>
+            </a:br>
+            <a:r>
+              <a:rPr lang="en-IL" sz="2800" dirty="0"/>
+              <a:t>better than both baselines at every threshold.</a:t>
+            </a:r>
+          </a:p>
+        </p:txBody>
+      </p:sp>
+      <p:sp>
+        <p:nvSpPr>
+          <p:cNvPr id="45" name="TextBox 44">
+            <a:extLst>
+              <a:ext uri="{FF2B5EF4-FFF2-40B4-BE49-F238E27FC236}">
+                <a16:creationId xmlns:a16="http://schemas.microsoft.com/office/drawing/2014/main" id="{CACC9749-2518-C6E3-5CBC-F0972626D493}"/>
+              </a:ext>
+            </a:extLst>
+          </p:cNvPr>
+          <p:cNvSpPr txBox="1"/>
+          <p:nvPr/>
+        </p:nvSpPr>
+        <p:spPr>
+          <a:xfrm>
+            <a:off x="1749538" y="26422504"/>
+            <a:ext cx="16883845" cy="1077218"/>
+          </a:xfrm>
+          <a:prstGeom prst="rect">
+            <a:avLst/>
+          </a:prstGeom>
+          <a:noFill/>
+        </p:spPr>
+        <p:txBody>
+          <a:bodyPr wrap="square" rtlCol="0">
+            <a:spAutoFit/>
+          </a:bodyPr>
+          <a:lstStyle/>
+          <a:p>
+            <a:r>
+              <a:rPr lang="en-IL" sz="3200" dirty="0"/>
+              <a:t>Two datasets are merged into 77k labeled wallets, turned into ego-graphs, and used to train our GATv2 model against tabular and graph baselines on a shared held-out test set.</a:t>
+            </a:r>
           </a:p>
         </p:txBody>
       </p:sp>

</xml_diff>